<commit_message>
Remove co-author references and recompile report/presentation
</commit_message>
<xml_diff>
--- a/presentation/presentation.pptx
+++ b/presentation/presentation.pptx
@@ -3319,23 +3319,7 @@
               </a:defRPr>
             </a:pPr>
             <a:r>
-              <a:t>Lead Author: Vedant Jharia  |  Email: vedant.jharia.btech2023@sitnagpur.siu.edu.in</a:t>
-            </a:r>
-          </a:p>
-          <a:p>
-            <a:pPr>
-              <a:spcBef>
-                <a:spcPts val="400"/>
-              </a:spcBef>
-              <a:defRPr sz="1200">
-                <a:solidFill>
-                  <a:srgbClr val="FFFFFF"/>
-                </a:solidFill>
-                <a:latin typeface="Arial"/>
-              </a:defRPr>
-            </a:pPr>
-            <a:r>
-              <a:t>Co-Author: [Co-Author / Team Member Name]  |  PRN: [Insert PRN]</a:t>
+              <a:t>Author: Vedant Jharia  |  Email: vedant.jharia.btech2023@sitnagpur.siu.edu.in</a:t>
             </a:r>
           </a:p>
           <a:p>

</xml_diff>